<commit_message>
added side layout to pptx
</commit_message>
<xml_diff>
--- a/PowerPoint/ARTS-Lab_USC_slide_template.pptx
+++ b/PowerPoint/ARTS-Lab_USC_slide_template.pptx
@@ -227,7 +227,7 @@
           <a:p>
             <a:fld id="{7D038C9C-4B69-864E-9EEE-DFA43CC144D2}" type="datetimeFigureOut">
               <a:rPr lang="en-US" smtClean="0"/>
-              <a:t>9/29/2025</a:t>
+              <a:t>4/11/2026</a:t>
             </a:fld>
             <a:endParaRPr lang="en-US"/>
           </a:p>
@@ -404,7 +404,7 @@
           <a:p>
             <a:fld id="{41D9A61E-B1D6-C34D-A321-B3E90F6DE630}" type="datetimeFigureOut">
               <a:rPr lang="en-US" smtClean="0"/>
-              <a:t>9/29/2025</a:t>
+              <a:t>4/11/2026</a:t>
             </a:fld>
             <a:endParaRPr lang="en-US"/>
           </a:p>
@@ -961,8 +961,8 @@
 </file>
 
 <file path=ppt/slideLayouts/slideLayout2.xml><?xml version="1.0" encoding="utf-8"?>
-<p:sldLayout xmlns:a="http://schemas.openxmlformats.org/drawingml/2006/main" xmlns:r="http://schemas.openxmlformats.org/officeDocument/2006/relationships" xmlns:p="http://schemas.openxmlformats.org/presentationml/2006/main" type="obj" preserve="1">
-  <p:cSld name="Title and Content">
+<p:sldLayout xmlns:a="http://schemas.openxmlformats.org/drawingml/2006/main" xmlns:r="http://schemas.openxmlformats.org/officeDocument/2006/relationships" xmlns:p="http://schemas.openxmlformats.org/presentationml/2006/main" preserve="1" userDrawn="1">
+  <p:cSld name="Side Content">
     <p:spTree>
       <p:nvGrpSpPr>
         <p:cNvPr id="1" name=""/>
@@ -982,7 +982,7 @@
           <p:cNvPr id="2" name="Title 1">
             <a:extLst>
               <a:ext uri="{FF2B5EF4-FFF2-40B4-BE49-F238E27FC236}">
-                <a16:creationId xmlns:a16="http://schemas.microsoft.com/office/drawing/2014/main" id="{6739ED37-4F17-3341-80DD-6302FD9C0346}"/>
+                <a16:creationId xmlns:a16="http://schemas.microsoft.com/office/drawing/2014/main" id="{A2BBC8D6-6BCB-BD4B-B6E0-92A778004EF5}"/>
               </a:ext>
             </a:extLst>
           </p:cNvPr>
@@ -1018,18 +1018,23 @@
           <p:cNvPr id="3" name="Content Placeholder 2">
             <a:extLst>
               <a:ext uri="{FF2B5EF4-FFF2-40B4-BE49-F238E27FC236}">
-                <a16:creationId xmlns:a16="http://schemas.microsoft.com/office/drawing/2014/main" id="{5456E732-1F86-874D-B35F-F0D15E08E919}"/>
-              </a:ext>
-            </a:extLst>
-          </p:cNvPr>
-          <p:cNvSpPr>
-            <a:spLocks noGrp="1"/>
-          </p:cNvSpPr>
-          <p:nvPr>
-            <p:ph idx="1"/>
-          </p:nvPr>
-        </p:nvSpPr>
-        <p:spPr/>
+                <a16:creationId xmlns:a16="http://schemas.microsoft.com/office/drawing/2014/main" id="{2BC4099C-8353-F44E-8406-26AC07974CEE}"/>
+              </a:ext>
+            </a:extLst>
+          </p:cNvPr>
+          <p:cNvSpPr>
+            <a:spLocks noGrp="1"/>
+          </p:cNvSpPr>
+          <p:nvPr>
+            <p:ph sz="half" idx="1"/>
+          </p:nvPr>
+        </p:nvSpPr>
+        <p:spPr>
+          <a:xfrm>
+            <a:off x="838200" y="1825625"/>
+            <a:ext cx="5181600" cy="4043761"/>
+          </a:xfrm>
+        </p:spPr>
         <p:txBody>
           <a:bodyPr/>
           <a:lstStyle>
@@ -1067,35 +1072,35 @@
           <a:p>
             <a:pPr lvl="0"/>
             <a:r>
-              <a:rPr lang="en-US"/>
+              <a:rPr lang="en-US" dirty="0"/>
               <a:t>Click to edit Master text styles</a:t>
             </a:r>
           </a:p>
           <a:p>
             <a:pPr lvl="1"/>
             <a:r>
-              <a:rPr lang="en-US"/>
+              <a:rPr lang="en-US" dirty="0"/>
               <a:t>Second level</a:t>
             </a:r>
           </a:p>
           <a:p>
             <a:pPr lvl="2"/>
             <a:r>
-              <a:rPr lang="en-US"/>
+              <a:rPr lang="en-US" dirty="0"/>
               <a:t>Third level</a:t>
             </a:r>
           </a:p>
           <a:p>
             <a:pPr lvl="3"/>
             <a:r>
-              <a:rPr lang="en-US"/>
+              <a:rPr lang="en-US" dirty="0"/>
               <a:t>Fourth level</a:t>
             </a:r>
           </a:p>
           <a:p>
             <a:pPr lvl="4"/>
             <a:r>
-              <a:rPr lang="en-US"/>
+              <a:rPr lang="en-US" dirty="0"/>
               <a:t>Fifth level</a:t>
             </a:r>
           </a:p>
@@ -1103,10 +1108,10 @@
       </p:sp>
       <p:sp>
         <p:nvSpPr>
-          <p:cNvPr id="5" name="Footer Placeholder 4">
-            <a:extLst>
-              <a:ext uri="{FF2B5EF4-FFF2-40B4-BE49-F238E27FC236}">
-                <a16:creationId xmlns:a16="http://schemas.microsoft.com/office/drawing/2014/main" id="{C2C13372-CC48-6246-83C0-B536F3DCA74E}"/>
+          <p:cNvPr id="6" name="Footer Placeholder 5">
+            <a:extLst>
+              <a:ext uri="{FF2B5EF4-FFF2-40B4-BE49-F238E27FC236}">
+                <a16:creationId xmlns:a16="http://schemas.microsoft.com/office/drawing/2014/main" id="{82CCBEF1-4544-884E-86EB-5374139098CC}"/>
               </a:ext>
             </a:extLst>
           </p:cNvPr>
@@ -1128,10 +1133,10 @@
       </p:sp>
       <p:sp>
         <p:nvSpPr>
-          <p:cNvPr id="6" name="Slide Number Placeholder 5">
-            <a:extLst>
-              <a:ext uri="{FF2B5EF4-FFF2-40B4-BE49-F238E27FC236}">
-                <a16:creationId xmlns:a16="http://schemas.microsoft.com/office/drawing/2014/main" id="{5B75CF31-8755-3E42-B89A-9D67D96D7102}"/>
+          <p:cNvPr id="7" name="Slide Number Placeholder 6">
+            <a:extLst>
+              <a:ext uri="{FF2B5EF4-FFF2-40B4-BE49-F238E27FC236}">
+                <a16:creationId xmlns:a16="http://schemas.microsoft.com/office/drawing/2014/main" id="{5277F880-2CCE-9044-8CE8-A7CF47CE5236}"/>
               </a:ext>
             </a:extLst>
           </p:cNvPr>
@@ -1145,7 +1150,7 @@
         <p:spPr>
           <a:xfrm>
             <a:off x="838200" y="6004323"/>
-            <a:ext cx="2635332" cy="365125"/>
+            <a:ext cx="2688771" cy="365125"/>
           </a:xfrm>
         </p:spPr>
         <p:txBody>
@@ -1163,7 +1168,7 @@
     </p:spTree>
     <p:extLst>
       <p:ext uri="{BB962C8B-B14F-4D97-AF65-F5344CB8AC3E}">
-        <p14:creationId xmlns:p14="http://schemas.microsoft.com/office/powerpoint/2010/main" val="306765995"/>
+        <p14:creationId xmlns:p14="http://schemas.microsoft.com/office/powerpoint/2010/main" val="3243886196"/>
       </p:ext>
     </p:extLst>
   </p:cSld>
@@ -1174,8 +1179,8 @@
 </file>
 
 <file path=ppt/slideLayouts/slideLayout3.xml><?xml version="1.0" encoding="utf-8"?>
-<p:sldLayout xmlns:a="http://schemas.openxmlformats.org/drawingml/2006/main" xmlns:r="http://schemas.openxmlformats.org/officeDocument/2006/relationships" xmlns:p="http://schemas.openxmlformats.org/presentationml/2006/main" type="twoObj" preserve="1">
-  <p:cSld name="Two Content">
+<p:sldLayout xmlns:a="http://schemas.openxmlformats.org/drawingml/2006/main" xmlns:r="http://schemas.openxmlformats.org/officeDocument/2006/relationships" xmlns:p="http://schemas.openxmlformats.org/presentationml/2006/main" type="obj" preserve="1">
+  <p:cSld name="Title and Content">
     <p:spTree>
       <p:nvGrpSpPr>
         <p:cNvPr id="1" name=""/>
@@ -1195,7 +1200,7 @@
           <p:cNvPr id="2" name="Title 1">
             <a:extLst>
               <a:ext uri="{FF2B5EF4-FFF2-40B4-BE49-F238E27FC236}">
-                <a16:creationId xmlns:a16="http://schemas.microsoft.com/office/drawing/2014/main" id="{A2BBC8D6-6BCB-BD4B-B6E0-92A778004EF5}"/>
+                <a16:creationId xmlns:a16="http://schemas.microsoft.com/office/drawing/2014/main" id="{6739ED37-4F17-3341-80DD-6302FD9C0346}"/>
               </a:ext>
             </a:extLst>
           </p:cNvPr>
@@ -1231,23 +1236,18 @@
           <p:cNvPr id="3" name="Content Placeholder 2">
             <a:extLst>
               <a:ext uri="{FF2B5EF4-FFF2-40B4-BE49-F238E27FC236}">
-                <a16:creationId xmlns:a16="http://schemas.microsoft.com/office/drawing/2014/main" id="{2BC4099C-8353-F44E-8406-26AC07974CEE}"/>
-              </a:ext>
-            </a:extLst>
-          </p:cNvPr>
-          <p:cNvSpPr>
-            <a:spLocks noGrp="1"/>
-          </p:cNvSpPr>
-          <p:nvPr>
-            <p:ph sz="half" idx="1"/>
-          </p:nvPr>
-        </p:nvSpPr>
-        <p:spPr>
-          <a:xfrm>
-            <a:off x="838200" y="1825625"/>
-            <a:ext cx="5181600" cy="4043761"/>
-          </a:xfrm>
-        </p:spPr>
+                <a16:creationId xmlns:a16="http://schemas.microsoft.com/office/drawing/2014/main" id="{5456E732-1F86-874D-B35F-F0D15E08E919}"/>
+              </a:ext>
+            </a:extLst>
+          </p:cNvPr>
+          <p:cNvSpPr>
+            <a:spLocks noGrp="1"/>
+          </p:cNvSpPr>
+          <p:nvPr>
+            <p:ph idx="1"/>
+          </p:nvPr>
+        </p:nvSpPr>
+        <p:spPr/>
         <p:txBody>
           <a:bodyPr/>
           <a:lstStyle>
@@ -1285,35 +1285,35 @@
           <a:p>
             <a:pPr lvl="0"/>
             <a:r>
-              <a:rPr lang="en-US" dirty="0"/>
+              <a:rPr lang="en-US"/>
               <a:t>Click to edit Master text styles</a:t>
             </a:r>
           </a:p>
           <a:p>
             <a:pPr lvl="1"/>
             <a:r>
-              <a:rPr lang="en-US" dirty="0"/>
+              <a:rPr lang="en-US"/>
               <a:t>Second level</a:t>
             </a:r>
           </a:p>
           <a:p>
             <a:pPr lvl="2"/>
             <a:r>
-              <a:rPr lang="en-US" dirty="0"/>
+              <a:rPr lang="en-US"/>
               <a:t>Third level</a:t>
             </a:r>
           </a:p>
           <a:p>
             <a:pPr lvl="3"/>
             <a:r>
-              <a:rPr lang="en-US" dirty="0"/>
+              <a:rPr lang="en-US"/>
               <a:t>Fourth level</a:t>
             </a:r>
           </a:p>
           <a:p>
             <a:pPr lvl="4"/>
             <a:r>
-              <a:rPr lang="en-US" dirty="0"/>
+              <a:rPr lang="en-US"/>
               <a:t>Fifth level</a:t>
             </a:r>
           </a:p>
@@ -1321,23 +1321,148 @@
       </p:sp>
       <p:sp>
         <p:nvSpPr>
-          <p:cNvPr id="4" name="Content Placeholder 3">
-            <a:extLst>
-              <a:ext uri="{FF2B5EF4-FFF2-40B4-BE49-F238E27FC236}">
-                <a16:creationId xmlns:a16="http://schemas.microsoft.com/office/drawing/2014/main" id="{F8F8CC49-08EF-8048-B6B2-BC247008F046}"/>
-              </a:ext>
-            </a:extLst>
-          </p:cNvPr>
-          <p:cNvSpPr>
-            <a:spLocks noGrp="1"/>
-          </p:cNvSpPr>
-          <p:nvPr>
-            <p:ph sz="half" idx="2"/>
+          <p:cNvPr id="5" name="Footer Placeholder 4">
+            <a:extLst>
+              <a:ext uri="{FF2B5EF4-FFF2-40B4-BE49-F238E27FC236}">
+                <a16:creationId xmlns:a16="http://schemas.microsoft.com/office/drawing/2014/main" id="{C2C13372-CC48-6246-83C0-B536F3DCA74E}"/>
+              </a:ext>
+            </a:extLst>
+          </p:cNvPr>
+          <p:cNvSpPr>
+            <a:spLocks noGrp="1"/>
+          </p:cNvSpPr>
+          <p:nvPr>
+            <p:ph type="ftr" sz="quarter" idx="11"/>
+          </p:nvPr>
+        </p:nvSpPr>
+        <p:spPr/>
+        <p:txBody>
+          <a:bodyPr/>
+          <a:lstStyle/>
+          <a:p>
+            <a:endParaRPr lang="en-US"/>
+          </a:p>
+        </p:txBody>
+      </p:sp>
+      <p:sp>
+        <p:nvSpPr>
+          <p:cNvPr id="6" name="Slide Number Placeholder 5">
+            <a:extLst>
+              <a:ext uri="{FF2B5EF4-FFF2-40B4-BE49-F238E27FC236}">
+                <a16:creationId xmlns:a16="http://schemas.microsoft.com/office/drawing/2014/main" id="{5B75CF31-8755-3E42-B89A-9D67D96D7102}"/>
+              </a:ext>
+            </a:extLst>
+          </p:cNvPr>
+          <p:cNvSpPr>
+            <a:spLocks noGrp="1"/>
+          </p:cNvSpPr>
+          <p:nvPr>
+            <p:ph type="sldNum" sz="quarter" idx="12"/>
           </p:nvPr>
         </p:nvSpPr>
         <p:spPr>
           <a:xfrm>
-            <a:off x="6172200" y="1825625"/>
+            <a:off x="838200" y="6004323"/>
+            <a:ext cx="2635332" cy="365125"/>
+          </a:xfrm>
+        </p:spPr>
+        <p:txBody>
+          <a:bodyPr/>
+          <a:lstStyle/>
+          <a:p>
+            <a:fld id="{B4E9AFF7-6653-6A4D-A979-64D2F5BECA26}" type="slidenum">
+              <a:rPr lang="en-US" smtClean="0"/>
+              <a:t>‹#›</a:t>
+            </a:fld>
+            <a:endParaRPr lang="en-US"/>
+          </a:p>
+        </p:txBody>
+      </p:sp>
+    </p:spTree>
+    <p:extLst>
+      <p:ext uri="{BB962C8B-B14F-4D97-AF65-F5344CB8AC3E}">
+        <p14:creationId xmlns:p14="http://schemas.microsoft.com/office/powerpoint/2010/main" val="306765995"/>
+      </p:ext>
+    </p:extLst>
+  </p:cSld>
+  <p:clrMapOvr>
+    <a:masterClrMapping/>
+  </p:clrMapOvr>
+</p:sldLayout>
+</file>
+
+<file path=ppt/slideLayouts/slideLayout4.xml><?xml version="1.0" encoding="utf-8"?>
+<p:sldLayout xmlns:a="http://schemas.openxmlformats.org/drawingml/2006/main" xmlns:r="http://schemas.openxmlformats.org/officeDocument/2006/relationships" xmlns:p="http://schemas.openxmlformats.org/presentationml/2006/main" type="twoObj" preserve="1">
+  <p:cSld name="Two Content">
+    <p:spTree>
+      <p:nvGrpSpPr>
+        <p:cNvPr id="1" name=""/>
+        <p:cNvGrpSpPr/>
+        <p:nvPr/>
+      </p:nvGrpSpPr>
+      <p:grpSpPr>
+        <a:xfrm>
+          <a:off x="0" y="0"/>
+          <a:ext cx="0" cy="0"/>
+          <a:chOff x="0" y="0"/>
+          <a:chExt cx="0" cy="0"/>
+        </a:xfrm>
+      </p:grpSpPr>
+      <p:sp>
+        <p:nvSpPr>
+          <p:cNvPr id="2" name="Title 1">
+            <a:extLst>
+              <a:ext uri="{FF2B5EF4-FFF2-40B4-BE49-F238E27FC236}">
+                <a16:creationId xmlns:a16="http://schemas.microsoft.com/office/drawing/2014/main" id="{A2BBC8D6-6BCB-BD4B-B6E0-92A778004EF5}"/>
+              </a:ext>
+            </a:extLst>
+          </p:cNvPr>
+          <p:cNvSpPr>
+            <a:spLocks noGrp="1"/>
+          </p:cNvSpPr>
+          <p:nvPr>
+            <p:ph type="title" hasCustomPrompt="1"/>
+          </p:nvPr>
+        </p:nvSpPr>
+        <p:spPr/>
+        <p:txBody>
+          <a:bodyPr>
+            <a:normAutofit/>
+          </a:bodyPr>
+          <a:lstStyle>
+            <a:lvl1pPr>
+              <a:defRPr sz="3600" cap="none">
+                <a:latin typeface="+mj-lt"/>
+              </a:defRPr>
+            </a:lvl1pPr>
+          </a:lstStyle>
+          <a:p>
+            <a:r>
+              <a:rPr lang="en-US" dirty="0"/>
+              <a:t>Click to edit master title style</a:t>
+            </a:r>
+          </a:p>
+        </p:txBody>
+      </p:sp>
+      <p:sp>
+        <p:nvSpPr>
+          <p:cNvPr id="3" name="Content Placeholder 2">
+            <a:extLst>
+              <a:ext uri="{FF2B5EF4-FFF2-40B4-BE49-F238E27FC236}">
+                <a16:creationId xmlns:a16="http://schemas.microsoft.com/office/drawing/2014/main" id="{2BC4099C-8353-F44E-8406-26AC07974CEE}"/>
+              </a:ext>
+            </a:extLst>
+          </p:cNvPr>
+          <p:cNvSpPr>
+            <a:spLocks noGrp="1"/>
+          </p:cNvSpPr>
+          <p:nvPr>
+            <p:ph sz="half" idx="1"/>
+          </p:nvPr>
+        </p:nvSpPr>
+        <p:spPr>
+          <a:xfrm>
+            <a:off x="838200" y="1825625"/>
             <a:ext cx="5181600" cy="4043761"/>
           </a:xfrm>
         </p:spPr>
@@ -1378,6 +1503,99 @@
           <a:p>
             <a:pPr lvl="0"/>
             <a:r>
+              <a:rPr lang="en-US" dirty="0"/>
+              <a:t>Click to edit Master text styles</a:t>
+            </a:r>
+          </a:p>
+          <a:p>
+            <a:pPr lvl="1"/>
+            <a:r>
+              <a:rPr lang="en-US" dirty="0"/>
+              <a:t>Second level</a:t>
+            </a:r>
+          </a:p>
+          <a:p>
+            <a:pPr lvl="2"/>
+            <a:r>
+              <a:rPr lang="en-US" dirty="0"/>
+              <a:t>Third level</a:t>
+            </a:r>
+          </a:p>
+          <a:p>
+            <a:pPr lvl="3"/>
+            <a:r>
+              <a:rPr lang="en-US" dirty="0"/>
+              <a:t>Fourth level</a:t>
+            </a:r>
+          </a:p>
+          <a:p>
+            <a:pPr lvl="4"/>
+            <a:r>
+              <a:rPr lang="en-US" dirty="0"/>
+              <a:t>Fifth level</a:t>
+            </a:r>
+          </a:p>
+        </p:txBody>
+      </p:sp>
+      <p:sp>
+        <p:nvSpPr>
+          <p:cNvPr id="4" name="Content Placeholder 3">
+            <a:extLst>
+              <a:ext uri="{FF2B5EF4-FFF2-40B4-BE49-F238E27FC236}">
+                <a16:creationId xmlns:a16="http://schemas.microsoft.com/office/drawing/2014/main" id="{F8F8CC49-08EF-8048-B6B2-BC247008F046}"/>
+              </a:ext>
+            </a:extLst>
+          </p:cNvPr>
+          <p:cNvSpPr>
+            <a:spLocks noGrp="1"/>
+          </p:cNvSpPr>
+          <p:nvPr>
+            <p:ph sz="half" idx="2"/>
+          </p:nvPr>
+        </p:nvSpPr>
+        <p:spPr>
+          <a:xfrm>
+            <a:off x="6172200" y="1825625"/>
+            <a:ext cx="5181600" cy="4043761"/>
+          </a:xfrm>
+        </p:spPr>
+        <p:txBody>
+          <a:bodyPr/>
+          <a:lstStyle>
+            <a:lvl1pPr>
+              <a:lnSpc>
+                <a:spcPct val="100000"/>
+              </a:lnSpc>
+              <a:defRPr/>
+            </a:lvl1pPr>
+            <a:lvl2pPr>
+              <a:lnSpc>
+                <a:spcPct val="100000"/>
+              </a:lnSpc>
+              <a:defRPr/>
+            </a:lvl2pPr>
+            <a:lvl3pPr>
+              <a:lnSpc>
+                <a:spcPct val="100000"/>
+              </a:lnSpc>
+              <a:defRPr/>
+            </a:lvl3pPr>
+            <a:lvl4pPr>
+              <a:lnSpc>
+                <a:spcPct val="100000"/>
+              </a:lnSpc>
+              <a:defRPr/>
+            </a:lvl4pPr>
+            <a:lvl5pPr>
+              <a:lnSpc>
+                <a:spcPct val="100000"/>
+              </a:lnSpc>
+              <a:defRPr/>
+            </a:lvl5pPr>
+          </a:lstStyle>
+          <a:p>
+            <a:pPr lvl="0"/>
+            <a:r>
               <a:rPr lang="en-US"/>
               <a:t>Click to edit Master text styles</a:t>
             </a:r>
@@ -1484,7 +1702,7 @@
 </p:sldLayout>
 </file>
 
-<file path=ppt/slideLayouts/slideLayout4.xml><?xml version="1.0" encoding="utf-8"?>
+<file path=ppt/slideLayouts/slideLayout5.xml><?xml version="1.0" encoding="utf-8"?>
 <p:sldLayout xmlns:a="http://schemas.openxmlformats.org/drawingml/2006/main" xmlns:r="http://schemas.openxmlformats.org/officeDocument/2006/relationships" xmlns:p="http://schemas.openxmlformats.org/presentationml/2006/main" type="titleOnly" preserve="1">
   <p:cSld name="Title Only">
     <p:spTree>
@@ -1609,7 +1827,7 @@
 </p:sldLayout>
 </file>
 
-<file path=ppt/slideLayouts/slideLayout5.xml><?xml version="1.0" encoding="utf-8"?>
+<file path=ppt/slideLayouts/slideLayout6.xml><?xml version="1.0" encoding="utf-8"?>
 <p:sldLayout xmlns:a="http://schemas.openxmlformats.org/drawingml/2006/main" xmlns:r="http://schemas.openxmlformats.org/officeDocument/2006/relationships" xmlns:p="http://schemas.openxmlformats.org/presentationml/2006/main" showMasterSp="0" type="secHead" preserve="1">
   <p:cSld name="Conclusion">
     <p:bg>
@@ -1863,7 +2081,7 @@
 </p:sldLayout>
 </file>
 
-<file path=ppt/slideLayouts/slideLayout6.xml><?xml version="1.0" encoding="utf-8"?>
+<file path=ppt/slideLayouts/slideLayout7.xml><?xml version="1.0" encoding="utf-8"?>
 <p:sldLayout xmlns:a="http://schemas.openxmlformats.org/drawingml/2006/main" xmlns:r="http://schemas.openxmlformats.org/officeDocument/2006/relationships" xmlns:p="http://schemas.openxmlformats.org/presentationml/2006/main" showMasterSp="0" preserve="1" userDrawn="1">
   <p:cSld name="Section Break">
     <p:bg>
@@ -1957,7 +2175,7 @@
     <p:bg>
       <p:bgPr>
         <a:blipFill dpi="0" rotWithShape="1">
-          <a:blip r:embed="rId8">
+          <a:blip r:embed="rId9">
             <a:lum/>
           </a:blip>
           <a:srcRect/>
@@ -2189,11 +2407,12 @@
   <p:clrMap bg1="lt1" tx1="dk1" bg2="lt2" tx2="dk2" accent1="accent1" accent2="accent2" accent3="accent3" accent4="accent4" accent5="accent5" accent6="accent6" hlink="hlink" folHlink="folHlink"/>
   <p:sldLayoutIdLst>
     <p:sldLayoutId id="2147483649" r:id="rId1"/>
-    <p:sldLayoutId id="2147483650" r:id="rId2"/>
-    <p:sldLayoutId id="2147483652" r:id="rId3"/>
-    <p:sldLayoutId id="2147483654" r:id="rId4"/>
-    <p:sldLayoutId id="2147483658" r:id="rId5"/>
-    <p:sldLayoutId id="2147483659" r:id="rId6"/>
+    <p:sldLayoutId id="2147483660" r:id="rId2"/>
+    <p:sldLayoutId id="2147483650" r:id="rId3"/>
+    <p:sldLayoutId id="2147483652" r:id="rId4"/>
+    <p:sldLayoutId id="2147483654" r:id="rId5"/>
+    <p:sldLayoutId id="2147483658" r:id="rId6"/>
+    <p:sldLayoutId id="2147483659" r:id="rId7"/>
   </p:sldLayoutIdLst>
   <p:hf hdr="0" ftr="0" dt="0"/>
   <p:txStyles>

</xml_diff>